<commit_message>
updated docs for SSI and aligned changes back to EnDat docs. Added driver functions for already existing pll debug ports, added tests, and docs for both SSI and EnDat. This is now a combined feature branch for SSI IP core driver and alignment updates to EnDat driver and docsgit commit -a!
</commit_message>
<xml_diff>
--- a/docs/source/ip_cores/uz_ssi_interface/ssi_figures.pptx
+++ b/docs/source/ip_cores/uz_ssi_interface/ssi_figures.pptx
@@ -6,7 +6,7 @@
   </p:sldMasterIdLst>
   <p:sldIdLst>
     <p:sldId id="256" r:id="rId2"/>
-    <p:sldId id="257" r:id="rId3"/>
+    <p:sldId id="258" r:id="rId3"/>
   </p:sldIdLst>
   <p:sldSz cx="12192000" cy="6858000"/>
   <p:notesSz cx="6858000" cy="9144000"/>
@@ -105,6 +105,11 @@
       </a:defRPr>
     </a:lvl9pPr>
   </p:defaultTextStyle>
+  <p:extLst>
+    <p:ext uri="{EFAFB233-063F-42B5-8137-9DF3F51BA10A}">
+      <p15:sldGuideLst xmlns:p15="http://schemas.microsoft.com/office/powerpoint/2012/main"/>
+    </p:ext>
+  </p:extLst>
 </p:presentation>
 </file>
 
@@ -255,7 +260,7 @@
           <a:p>
             <a:fld id="{7E2356D3-E30D-44B7-AFFE-AEB9BA27F901}" type="datetimeFigureOut">
               <a:rPr lang="de-DE" smtClean="0"/>
-              <a:t>27.04.2026</a:t>
+              <a:t>08.05.2026</a:t>
             </a:fld>
             <a:endParaRPr lang="de-DE"/>
           </a:p>
@@ -453,7 +458,7 @@
           <a:p>
             <a:fld id="{7E2356D3-E30D-44B7-AFFE-AEB9BA27F901}" type="datetimeFigureOut">
               <a:rPr lang="de-DE" smtClean="0"/>
-              <a:t>27.04.2026</a:t>
+              <a:t>08.05.2026</a:t>
             </a:fld>
             <a:endParaRPr lang="de-DE"/>
           </a:p>
@@ -661,7 +666,7 @@
           <a:p>
             <a:fld id="{7E2356D3-E30D-44B7-AFFE-AEB9BA27F901}" type="datetimeFigureOut">
               <a:rPr lang="de-DE" smtClean="0"/>
-              <a:t>27.04.2026</a:t>
+              <a:t>08.05.2026</a:t>
             </a:fld>
             <a:endParaRPr lang="de-DE"/>
           </a:p>
@@ -859,7 +864,7 @@
           <a:p>
             <a:fld id="{7E2356D3-E30D-44B7-AFFE-AEB9BA27F901}" type="datetimeFigureOut">
               <a:rPr lang="de-DE" smtClean="0"/>
-              <a:t>27.04.2026</a:t>
+              <a:t>08.05.2026</a:t>
             </a:fld>
             <a:endParaRPr lang="de-DE"/>
           </a:p>
@@ -1134,7 +1139,7 @@
           <a:p>
             <a:fld id="{7E2356D3-E30D-44B7-AFFE-AEB9BA27F901}" type="datetimeFigureOut">
               <a:rPr lang="de-DE" smtClean="0"/>
-              <a:t>27.04.2026</a:t>
+              <a:t>08.05.2026</a:t>
             </a:fld>
             <a:endParaRPr lang="de-DE"/>
           </a:p>
@@ -1399,7 +1404,7 @@
           <a:p>
             <a:fld id="{7E2356D3-E30D-44B7-AFFE-AEB9BA27F901}" type="datetimeFigureOut">
               <a:rPr lang="de-DE" smtClean="0"/>
-              <a:t>27.04.2026</a:t>
+              <a:t>08.05.2026</a:t>
             </a:fld>
             <a:endParaRPr lang="de-DE"/>
           </a:p>
@@ -1811,7 +1816,7 @@
           <a:p>
             <a:fld id="{7E2356D3-E30D-44B7-AFFE-AEB9BA27F901}" type="datetimeFigureOut">
               <a:rPr lang="de-DE" smtClean="0"/>
-              <a:t>27.04.2026</a:t>
+              <a:t>08.05.2026</a:t>
             </a:fld>
             <a:endParaRPr lang="de-DE"/>
           </a:p>
@@ -1952,7 +1957,7 @@
           <a:p>
             <a:fld id="{7E2356D3-E30D-44B7-AFFE-AEB9BA27F901}" type="datetimeFigureOut">
               <a:rPr lang="de-DE" smtClean="0"/>
-              <a:t>27.04.2026</a:t>
+              <a:t>08.05.2026</a:t>
             </a:fld>
             <a:endParaRPr lang="de-DE"/>
           </a:p>
@@ -2065,7 +2070,7 @@
           <a:p>
             <a:fld id="{7E2356D3-E30D-44B7-AFFE-AEB9BA27F901}" type="datetimeFigureOut">
               <a:rPr lang="de-DE" smtClean="0"/>
-              <a:t>27.04.2026</a:t>
+              <a:t>08.05.2026</a:t>
             </a:fld>
             <a:endParaRPr lang="de-DE"/>
           </a:p>
@@ -2376,7 +2381,7 @@
           <a:p>
             <a:fld id="{7E2356D3-E30D-44B7-AFFE-AEB9BA27F901}" type="datetimeFigureOut">
               <a:rPr lang="de-DE" smtClean="0"/>
-              <a:t>27.04.2026</a:t>
+              <a:t>08.05.2026</a:t>
             </a:fld>
             <a:endParaRPr lang="de-DE"/>
           </a:p>
@@ -2664,7 +2669,7 @@
           <a:p>
             <a:fld id="{7E2356D3-E30D-44B7-AFFE-AEB9BA27F901}" type="datetimeFigureOut">
               <a:rPr lang="de-DE" smtClean="0"/>
-              <a:t>27.04.2026</a:t>
+              <a:t>08.05.2026</a:t>
             </a:fld>
             <a:endParaRPr lang="de-DE"/>
           </a:p>
@@ -2905,7 +2910,7 @@
           <a:p>
             <a:fld id="{7E2356D3-E30D-44B7-AFFE-AEB9BA27F901}" type="datetimeFigureOut">
               <a:rPr lang="de-DE" smtClean="0"/>
-              <a:t>27.04.2026</a:t>
+              <a:t>08.05.2026</a:t>
             </a:fld>
             <a:endParaRPr lang="de-DE"/>
           </a:p>
@@ -3909,7 +3914,7 @@
         <p:cNvPr id="1" name="">
           <a:extLst>
             <a:ext uri="{FF2B5EF4-FFF2-40B4-BE49-F238E27FC236}">
-              <a16:creationId xmlns:a16="http://schemas.microsoft.com/office/drawing/2014/main" id="{6D55B969-F351-34D6-B7E4-E7E4372B98C0}"/>
+              <a16:creationId xmlns:a16="http://schemas.microsoft.com/office/drawing/2014/main" id="{AA03560E-5EF3-8CEE-5D8A-435BDDFA52C3}"/>
             </a:ext>
           </a:extLst>
         </p:cNvPr>
@@ -3926,10 +3931,10 @@
       </p:grpSpPr>
       <p:pic>
         <p:nvPicPr>
-          <p:cNvPr id="8" name="Grafik 7">
-            <a:extLst>
-              <a:ext uri="{FF2B5EF4-FFF2-40B4-BE49-F238E27FC236}">
-                <a16:creationId xmlns:a16="http://schemas.microsoft.com/office/drawing/2014/main" id="{094599B2-F85C-244B-AAB3-46B3246B2475}"/>
+          <p:cNvPr id="3" name="Grafik 2">
+            <a:extLst>
+              <a:ext uri="{FF2B5EF4-FFF2-40B4-BE49-F238E27FC236}">
+                <a16:creationId xmlns:a16="http://schemas.microsoft.com/office/drawing/2014/main" id="{49EDBB39-140D-E2E6-75AC-7CFDAB41EA19}"/>
               </a:ext>
             </a:extLst>
           </p:cNvPr>
@@ -3946,8 +3951,8 @@
         </p:blipFill>
         <p:spPr>
           <a:xfrm>
-            <a:off x="8531351" y="1917250"/>
-            <a:ext cx="1682836" cy="273064"/>
+            <a:off x="3071412" y="3117566"/>
+            <a:ext cx="1263715" cy="311166"/>
           </a:xfrm>
           <a:prstGeom prst="rect">
             <a:avLst/>
@@ -3956,10 +3961,10 @@
       </p:pic>
       <p:pic>
         <p:nvPicPr>
-          <p:cNvPr id="5" name="Grafik 4">
-            <a:extLst>
-              <a:ext uri="{FF2B5EF4-FFF2-40B4-BE49-F238E27FC236}">
-                <a16:creationId xmlns:a16="http://schemas.microsoft.com/office/drawing/2014/main" id="{45C0BBD4-FF20-2D99-14EC-75E6A3C4A5F0}"/>
+          <p:cNvPr id="9" name="Grafik 8">
+            <a:extLst>
+              <a:ext uri="{FF2B5EF4-FFF2-40B4-BE49-F238E27FC236}">
+                <a16:creationId xmlns:a16="http://schemas.microsoft.com/office/drawing/2014/main" id="{5195DC44-18FF-C6EF-89AC-8C515AA4416B}"/>
               </a:ext>
             </a:extLst>
           </p:cNvPr>
@@ -3976,38 +3981,8 @@
         </p:blipFill>
         <p:spPr>
           <a:xfrm>
-            <a:off x="3641599" y="1320691"/>
-            <a:ext cx="4908802" cy="4216617"/>
-          </a:xfrm>
-          <a:prstGeom prst="rect">
-            <a:avLst/>
-          </a:prstGeom>
-        </p:spPr>
-      </p:pic>
-      <p:pic>
-        <p:nvPicPr>
-          <p:cNvPr id="3" name="Grafik 2">
-            <a:extLst>
-              <a:ext uri="{FF2B5EF4-FFF2-40B4-BE49-F238E27FC236}">
-                <a16:creationId xmlns:a16="http://schemas.microsoft.com/office/drawing/2014/main" id="{94B807BA-BBD7-BC76-D0E4-9C997A7CBBC5}"/>
-              </a:ext>
-            </a:extLst>
-          </p:cNvPr>
-          <p:cNvPicPr>
-            <a:picLocks noChangeAspect="1"/>
-          </p:cNvPicPr>
-          <p:nvPr/>
-        </p:nvPicPr>
-        <p:blipFill>
-          <a:blip r:embed="rId4"/>
-          <a:stretch>
-            <a:fillRect/>
-          </a:stretch>
-        </p:blipFill>
-        <p:spPr>
-          <a:xfrm>
-            <a:off x="2428684" y="3276591"/>
-            <a:ext cx="1263715" cy="311166"/>
+            <a:off x="2889037" y="3362472"/>
+            <a:ext cx="1286458" cy="315182"/>
           </a:xfrm>
           <a:prstGeom prst="rect">
             <a:avLst/>
@@ -4019,7 +3994,7 @@
           <p:cNvPr id="6" name="Grafik 5">
             <a:extLst>
               <a:ext uri="{FF2B5EF4-FFF2-40B4-BE49-F238E27FC236}">
-                <a16:creationId xmlns:a16="http://schemas.microsoft.com/office/drawing/2014/main" id="{097B7A76-CA65-F599-C6B3-0E873619BFCC}"/>
+                <a16:creationId xmlns:a16="http://schemas.microsoft.com/office/drawing/2014/main" id="{8A3522D2-CBA3-ED1B-8633-52DD5F5A2FED}"/>
               </a:ext>
             </a:extLst>
           </p:cNvPr>
@@ -4029,7 +4004,7 @@
           <p:nvPr/>
         </p:nvPicPr>
         <p:blipFill>
-          <a:blip r:embed="rId5"/>
+          <a:blip r:embed="rId4"/>
           <a:srcRect b="25861"/>
           <a:stretch>
             <a:fillRect/>
@@ -4037,7 +4012,7 @@
         </p:blipFill>
         <p:spPr>
           <a:xfrm>
-            <a:off x="8417338" y="1663237"/>
+            <a:off x="8317948" y="1663237"/>
             <a:ext cx="1568531" cy="273065"/>
           </a:xfrm>
           <a:prstGeom prst="rect">
@@ -4050,7 +4025,37 @@
           <p:cNvPr id="10" name="Grafik 9">
             <a:extLst>
               <a:ext uri="{FF2B5EF4-FFF2-40B4-BE49-F238E27FC236}">
-                <a16:creationId xmlns:a16="http://schemas.microsoft.com/office/drawing/2014/main" id="{AB54B3DC-4AAD-25E3-5E57-CB86349EBCDC}"/>
+                <a16:creationId xmlns:a16="http://schemas.microsoft.com/office/drawing/2014/main" id="{E9A37D85-5289-5C18-F187-36464835E375}"/>
+              </a:ext>
+            </a:extLst>
+          </p:cNvPr>
+          <p:cNvPicPr>
+            <a:picLocks noChangeAspect="1"/>
+          </p:cNvPicPr>
+          <p:nvPr/>
+        </p:nvPicPr>
+        <p:blipFill>
+          <a:blip r:embed="rId5"/>
+          <a:stretch>
+            <a:fillRect/>
+          </a:stretch>
+        </p:blipFill>
+        <p:spPr>
+          <a:xfrm>
+            <a:off x="8451288" y="1933182"/>
+            <a:ext cx="1638384" cy="285765"/>
+          </a:xfrm>
+          <a:prstGeom prst="rect">
+            <a:avLst/>
+          </a:prstGeom>
+        </p:spPr>
+      </p:pic>
+      <p:pic>
+        <p:nvPicPr>
+          <p:cNvPr id="12" name="Grafik 11">
+            <a:extLst>
+              <a:ext uri="{FF2B5EF4-FFF2-40B4-BE49-F238E27FC236}">
+                <a16:creationId xmlns:a16="http://schemas.microsoft.com/office/drawing/2014/main" id="{4EE8BA87-E72F-3D7B-797A-79D77F24C24C}"/>
               </a:ext>
             </a:extLst>
           </p:cNvPr>
@@ -4067,8 +4072,8 @@
         </p:blipFill>
         <p:spPr>
           <a:xfrm>
-            <a:off x="8544052" y="2151840"/>
-            <a:ext cx="1638384" cy="285765"/>
+            <a:off x="8405935" y="2174675"/>
+            <a:ext cx="1790792" cy="279414"/>
           </a:xfrm>
           <a:prstGeom prst="rect">
             <a:avLst/>
@@ -4077,10 +4082,10 @@
       </p:pic>
       <p:pic>
         <p:nvPicPr>
-          <p:cNvPr id="12" name="Grafik 11">
-            <a:extLst>
-              <a:ext uri="{FF2B5EF4-FFF2-40B4-BE49-F238E27FC236}">
-                <a16:creationId xmlns:a16="http://schemas.microsoft.com/office/drawing/2014/main" id="{A94DA52E-FD16-A5E3-1DAF-88F2E0857877}"/>
+          <p:cNvPr id="4" name="Grafik 3">
+            <a:extLst>
+              <a:ext uri="{FF2B5EF4-FFF2-40B4-BE49-F238E27FC236}">
+                <a16:creationId xmlns:a16="http://schemas.microsoft.com/office/drawing/2014/main" id="{8360D452-C156-56EF-6B65-47D08282ED10}"/>
               </a:ext>
             </a:extLst>
           </p:cNvPr>
@@ -4097,38 +4102,8 @@
         </p:blipFill>
         <p:spPr>
           <a:xfrm>
-            <a:off x="8505325" y="2380081"/>
-            <a:ext cx="1790792" cy="279414"/>
-          </a:xfrm>
-          <a:prstGeom prst="rect">
-            <a:avLst/>
-          </a:prstGeom>
-        </p:spPr>
-      </p:pic>
-      <p:pic>
-        <p:nvPicPr>
-          <p:cNvPr id="14" name="Grafik 13">
-            <a:extLst>
-              <a:ext uri="{FF2B5EF4-FFF2-40B4-BE49-F238E27FC236}">
-                <a16:creationId xmlns:a16="http://schemas.microsoft.com/office/drawing/2014/main" id="{22D9004B-F486-76AC-8D09-D3142DFC3286}"/>
-              </a:ext>
-            </a:extLst>
-          </p:cNvPr>
-          <p:cNvPicPr>
-            <a:picLocks noChangeAspect="1"/>
-          </p:cNvPicPr>
-          <p:nvPr/>
-        </p:nvPicPr>
-        <p:blipFill>
-          <a:blip r:embed="rId8"/>
-          <a:stretch>
-            <a:fillRect/>
-          </a:stretch>
-        </p:blipFill>
-        <p:spPr>
-          <a:xfrm>
-            <a:off x="2365182" y="3530593"/>
-            <a:ext cx="1301817" cy="260363"/>
+            <a:off x="4172868" y="1232828"/>
+            <a:ext cx="4323764" cy="3935481"/>
           </a:xfrm>
           <a:prstGeom prst="rect">
             <a:avLst/>
@@ -4138,7 +4113,7 @@
     </p:spTree>
     <p:extLst>
       <p:ext uri="{BB962C8B-B14F-4D97-AF65-F5344CB8AC3E}">
-        <p14:creationId xmlns:p14="http://schemas.microsoft.com/office/powerpoint/2010/main" val="3940302557"/>
+        <p14:creationId xmlns:p14="http://schemas.microsoft.com/office/powerpoint/2010/main" val="2472032001"/>
       </p:ext>
     </p:extLst>
   </p:cSld>

</xml_diff>